<commit_message>
adding participator excel to readme
</commit_message>
<xml_diff>
--- a/slides/Day3-ws3-network-metrics-SZB.pptx
+++ b/slides/Day3-ws3-network-metrics-SZB.pptx
@@ -166,7 +166,7 @@
 <file path=ppt/revisionInfo.xml><?xml version="1.0" encoding="utf-8"?>
 <p1510:revInfo xmlns:a="http://schemas.openxmlformats.org/drawingml/2006/main" xmlns:r="http://schemas.openxmlformats.org/officeDocument/2006/relationships" xmlns:p1510="http://schemas.microsoft.com/office/powerpoint/2015/10/main">
   <p1510:revLst>
-    <p1510:client id="{DAB2256D-C388-4933-9DAA-3B651D5FD41A}" v="2" dt="2026-04-29T13:07:00.777"/>
+    <p1510:client id="{85FDCCBC-DCAB-447E-9B88-DFC2B99C3FF8}" v="1" dt="2026-05-01T07:28:54.518"/>
   </p1510:revLst>
 </p1510:revInfo>
 </file>
@@ -176,7 +176,7 @@
   <pc:docChgLst>
     <pc:chgData name="Botond Szemes" userId="9ad5295e-c011-431e-9933-da85a69d50eb" providerId="ADAL" clId="{FE312727-2FF1-41BE-81FD-03C074F4A432}"/>
     <pc:docChg chg="undo custSel addSld delSld modSld sldOrd">
-      <pc:chgData name="Botond Szemes" userId="9ad5295e-c011-431e-9933-da85a69d50eb" providerId="ADAL" clId="{FE312727-2FF1-41BE-81FD-03C074F4A432}" dt="2026-04-29T13:07:39.802" v="3149" actId="20577"/>
+      <pc:chgData name="Botond Szemes" userId="9ad5295e-c011-431e-9933-da85a69d50eb" providerId="ADAL" clId="{FE312727-2FF1-41BE-81FD-03C074F4A432}" dt="2026-05-01T07:29:07.837" v="3188" actId="20577"/>
       <pc:docMkLst>
         <pc:docMk/>
       </pc:docMkLst>
@@ -196,7 +196,7 @@
         </pc:spChg>
       </pc:sldChg>
       <pc:sldChg chg="modSp mod ord">
-        <pc:chgData name="Botond Szemes" userId="9ad5295e-c011-431e-9933-da85a69d50eb" providerId="ADAL" clId="{FE312727-2FF1-41BE-81FD-03C074F4A432}" dt="2026-04-08T11:29:09.636" v="2694" actId="113"/>
+        <pc:chgData name="Botond Szemes" userId="9ad5295e-c011-431e-9933-da85a69d50eb" providerId="ADAL" clId="{FE312727-2FF1-41BE-81FD-03C074F4A432}" dt="2026-05-01T07:29:07.837" v="3188" actId="20577"/>
         <pc:sldMkLst>
           <pc:docMk/>
           <pc:sldMk cId="273041768" sldId="258"/>
@@ -210,7 +210,7 @@
           </ac:spMkLst>
         </pc:spChg>
         <pc:spChg chg="mod">
-          <ac:chgData name="Botond Szemes" userId="9ad5295e-c011-431e-9933-da85a69d50eb" providerId="ADAL" clId="{FE312727-2FF1-41BE-81FD-03C074F4A432}" dt="2026-04-08T11:29:09.636" v="2694" actId="113"/>
+          <ac:chgData name="Botond Szemes" userId="9ad5295e-c011-431e-9933-da85a69d50eb" providerId="ADAL" clId="{FE312727-2FF1-41BE-81FD-03C074F4A432}" dt="2026-05-01T07:29:07.837" v="3188" actId="20577"/>
           <ac:spMkLst>
             <pc:docMk/>
             <pc:sldMk cId="273041768" sldId="258"/>
@@ -254,14 +254,6 @@
           <pc:docMk/>
           <pc:sldMk cId="1952504440" sldId="262"/>
         </pc:sldMkLst>
-        <pc:spChg chg="add mod">
-          <ac:chgData name="Botond Szemes" userId="9ad5295e-c011-431e-9933-da85a69d50eb" providerId="ADAL" clId="{FE312727-2FF1-41BE-81FD-03C074F4A432}" dt="2026-03-31T13:30:22.314" v="36" actId="255"/>
-          <ac:spMkLst>
-            <pc:docMk/>
-            <pc:sldMk cId="1952504440" sldId="262"/>
-            <ac:spMk id="2" creationId="{2CF9E405-97A1-2280-1B56-1A04F4670166}"/>
-          </ac:spMkLst>
-        </pc:spChg>
       </pc:sldChg>
       <pc:sldChg chg="addSp delSp modSp new mod ord delAnim modAnim">
         <pc:chgData name="Botond Szemes" userId="9ad5295e-c011-431e-9933-da85a69d50eb" providerId="ADAL" clId="{FE312727-2FF1-41BE-81FD-03C074F4A432}" dt="2026-04-08T11:25:11.753" v="2651" actId="20577"/>
@@ -277,14 +269,6 @@
             <ac:spMk id="2" creationId="{41AAB94D-132A-E55C-5C2F-21657833EE09}"/>
           </ac:spMkLst>
         </pc:spChg>
-        <pc:spChg chg="mod">
-          <ac:chgData name="Botond Szemes" userId="9ad5295e-c011-431e-9933-da85a69d50eb" providerId="ADAL" clId="{FE312727-2FF1-41BE-81FD-03C074F4A432}" dt="2026-03-31T13:50:12.342" v="141" actId="1076"/>
-          <ac:spMkLst>
-            <pc:docMk/>
-            <pc:sldMk cId="3541985138" sldId="263"/>
-            <ac:spMk id="3" creationId="{0A01501F-1127-72A6-F7C6-1057C9BBE6B1}"/>
-          </ac:spMkLst>
-        </pc:spChg>
         <pc:spChg chg="add mod">
           <ac:chgData name="Botond Szemes" userId="9ad5295e-c011-431e-9933-da85a69d50eb" providerId="ADAL" clId="{FE312727-2FF1-41BE-81FD-03C074F4A432}" dt="2026-04-01T06:43:20.443" v="738" actId="1076"/>
           <ac:spMkLst>
@@ -293,14 +277,6 @@
             <ac:spMk id="116" creationId="{44FE5083-1E36-5DA9-3C28-52CD973B89DD}"/>
           </ac:spMkLst>
         </pc:spChg>
-        <pc:picChg chg="add mod">
-          <ac:chgData name="Botond Szemes" userId="9ad5295e-c011-431e-9933-da85a69d50eb" providerId="ADAL" clId="{FE312727-2FF1-41BE-81FD-03C074F4A432}" dt="2026-03-31T14:35:23.557" v="446" actId="1076"/>
-          <ac:picMkLst>
-            <pc:docMk/>
-            <pc:sldMk cId="3541985138" sldId="263"/>
-            <ac:picMk id="7" creationId="{E7343A62-74BE-933B-F411-4064AEF8BED8}"/>
-          </ac:picMkLst>
-        </pc:picChg>
         <pc:picChg chg="add mod">
           <ac:chgData name="Botond Szemes" userId="9ad5295e-c011-431e-9933-da85a69d50eb" providerId="ADAL" clId="{FE312727-2FF1-41BE-81FD-03C074F4A432}" dt="2026-04-01T06:37:35.644" v="679" actId="1076"/>
           <ac:picMkLst>
@@ -420,14 +396,6 @@
             <ac:spMk id="2" creationId="{02EBCFB2-6AE5-01C5-E897-5BACF4C3140C}"/>
           </ac:spMkLst>
         </pc:spChg>
-        <pc:spChg chg="mod">
-          <ac:chgData name="Botond Szemes" userId="9ad5295e-c011-431e-9933-da85a69d50eb" providerId="ADAL" clId="{FE312727-2FF1-41BE-81FD-03C074F4A432}" dt="2026-03-31T13:51:02.920" v="151" actId="113"/>
-          <ac:spMkLst>
-            <pc:docMk/>
-            <pc:sldMk cId="1657533473" sldId="264"/>
-            <ac:spMk id="3" creationId="{58F52D3E-AACE-EE8B-55D7-85F35A18F70A}"/>
-          </ac:spMkLst>
-        </pc:spChg>
       </pc:sldChg>
       <pc:sldChg chg="addSp delSp modSp new mod ord addAnim delAnim modAnim">
         <pc:chgData name="Botond Szemes" userId="9ad5295e-c011-431e-9933-da85a69d50eb" providerId="ADAL" clId="{FE312727-2FF1-41BE-81FD-03C074F4A432}" dt="2026-04-09T13:42:25.130" v="3034" actId="20577"/>
@@ -436,147 +404,11 @@
           <pc:sldMk cId="3140339783" sldId="266"/>
         </pc:sldMkLst>
         <pc:spChg chg="add mod">
-          <ac:chgData name="Botond Szemes" userId="9ad5295e-c011-431e-9933-da85a69d50eb" providerId="ADAL" clId="{FE312727-2FF1-41BE-81FD-03C074F4A432}" dt="2026-03-31T13:55:17.443" v="162" actId="14100"/>
-          <ac:spMkLst>
-            <pc:docMk/>
-            <pc:sldMk cId="3140339783" sldId="266"/>
-            <ac:spMk id="5" creationId="{43CD3441-1944-1DE0-58C8-360ED9DB64FD}"/>
-          </ac:spMkLst>
-        </pc:spChg>
-        <pc:spChg chg="add mod">
-          <ac:chgData name="Botond Szemes" userId="9ad5295e-c011-431e-9933-da85a69d50eb" providerId="ADAL" clId="{FE312727-2FF1-41BE-81FD-03C074F4A432}" dt="2026-03-31T13:55:52.353" v="164" actId="1076"/>
-          <ac:spMkLst>
-            <pc:docMk/>
-            <pc:sldMk cId="3140339783" sldId="266"/>
-            <ac:spMk id="6" creationId="{88985F43-EF7E-CC6F-F61E-97D62F045D08}"/>
-          </ac:spMkLst>
-        </pc:spChg>
-        <pc:spChg chg="add mod">
-          <ac:chgData name="Botond Szemes" userId="9ad5295e-c011-431e-9933-da85a69d50eb" providerId="ADAL" clId="{FE312727-2FF1-41BE-81FD-03C074F4A432}" dt="2026-03-31T13:56:06.906" v="167" actId="207"/>
-          <ac:spMkLst>
-            <pc:docMk/>
-            <pc:sldMk cId="3140339783" sldId="266"/>
-            <ac:spMk id="7" creationId="{0F090795-0C6D-4754-1F64-FED913373930}"/>
-          </ac:spMkLst>
-        </pc:spChg>
-        <pc:spChg chg="add mod">
-          <ac:chgData name="Botond Szemes" userId="9ad5295e-c011-431e-9933-da85a69d50eb" providerId="ADAL" clId="{FE312727-2FF1-41BE-81FD-03C074F4A432}" dt="2026-03-31T13:56:11.914" v="170" actId="207"/>
-          <ac:spMkLst>
-            <pc:docMk/>
-            <pc:sldMk cId="3140339783" sldId="266"/>
-            <ac:spMk id="8" creationId="{5442FDFB-4D8A-B076-358D-BACCE189C085}"/>
-          </ac:spMkLst>
-        </pc:spChg>
-        <pc:spChg chg="add mod">
-          <ac:chgData name="Botond Szemes" userId="9ad5295e-c011-431e-9933-da85a69d50eb" providerId="ADAL" clId="{FE312727-2FF1-41BE-81FD-03C074F4A432}" dt="2026-03-31T13:56:21.004" v="173" actId="207"/>
-          <ac:spMkLst>
-            <pc:docMk/>
-            <pc:sldMk cId="3140339783" sldId="266"/>
-            <ac:spMk id="9" creationId="{3B45CA51-BE4C-A18D-3179-BE177D79F528}"/>
-          </ac:spMkLst>
-        </pc:spChg>
-        <pc:spChg chg="add mod">
-          <ac:chgData name="Botond Szemes" userId="9ad5295e-c011-431e-9933-da85a69d50eb" providerId="ADAL" clId="{FE312727-2FF1-41BE-81FD-03C074F4A432}" dt="2026-03-31T13:56:25.883" v="176" actId="207"/>
-          <ac:spMkLst>
-            <pc:docMk/>
-            <pc:sldMk cId="3140339783" sldId="266"/>
-            <ac:spMk id="10" creationId="{3CFA2D08-0A59-35BB-9EB7-4F02649C8C4F}"/>
-          </ac:spMkLst>
-        </pc:spChg>
-        <pc:spChg chg="add mod">
-          <ac:chgData name="Botond Szemes" userId="9ad5295e-c011-431e-9933-da85a69d50eb" providerId="ADAL" clId="{FE312727-2FF1-41BE-81FD-03C074F4A432}" dt="2026-03-31T13:56:39.927" v="180" actId="207"/>
-          <ac:spMkLst>
-            <pc:docMk/>
-            <pc:sldMk cId="3140339783" sldId="266"/>
-            <ac:spMk id="11" creationId="{CE9F97C8-AD36-96C0-7725-6CB47CFFCFBE}"/>
-          </ac:spMkLst>
-        </pc:spChg>
-        <pc:spChg chg="add mod">
-          <ac:chgData name="Botond Szemes" userId="9ad5295e-c011-431e-9933-da85a69d50eb" providerId="ADAL" clId="{FE312727-2FF1-41BE-81FD-03C074F4A432}" dt="2026-03-31T13:56:45.787" v="183" actId="207"/>
-          <ac:spMkLst>
-            <pc:docMk/>
-            <pc:sldMk cId="3140339783" sldId="266"/>
-            <ac:spMk id="12" creationId="{E13B4ACD-DA87-68D1-DCAA-49ACED6ABF44}"/>
-          </ac:spMkLst>
-        </pc:spChg>
-        <pc:spChg chg="add mod">
-          <ac:chgData name="Botond Szemes" userId="9ad5295e-c011-431e-9933-da85a69d50eb" providerId="ADAL" clId="{FE312727-2FF1-41BE-81FD-03C074F4A432}" dt="2026-03-31T13:56:52.491" v="186" actId="207"/>
-          <ac:spMkLst>
-            <pc:docMk/>
-            <pc:sldMk cId="3140339783" sldId="266"/>
-            <ac:spMk id="13" creationId="{870D0256-1BF8-9A37-88DF-F1BB1B93D69E}"/>
-          </ac:spMkLst>
-        </pc:spChg>
-        <pc:spChg chg="add mod">
-          <ac:chgData name="Botond Szemes" userId="9ad5295e-c011-431e-9933-da85a69d50eb" providerId="ADAL" clId="{FE312727-2FF1-41BE-81FD-03C074F4A432}" dt="2026-03-31T13:56:58.808" v="189" actId="207"/>
-          <ac:spMkLst>
-            <pc:docMk/>
-            <pc:sldMk cId="3140339783" sldId="266"/>
-            <ac:spMk id="14" creationId="{F6C17D72-A3E3-AE0C-AB35-3E21762CC261}"/>
-          </ac:spMkLst>
-        </pc:spChg>
-        <pc:spChg chg="add mod">
-          <ac:chgData name="Botond Szemes" userId="9ad5295e-c011-431e-9933-da85a69d50eb" providerId="ADAL" clId="{FE312727-2FF1-41BE-81FD-03C074F4A432}" dt="2026-03-31T13:57:04.014" v="192" actId="207"/>
-          <ac:spMkLst>
-            <pc:docMk/>
-            <pc:sldMk cId="3140339783" sldId="266"/>
-            <ac:spMk id="15" creationId="{AE006D2C-913A-D2E9-6CB7-0B4BF8380D0E}"/>
-          </ac:spMkLst>
-        </pc:spChg>
-        <pc:spChg chg="add mod">
-          <ac:chgData name="Botond Szemes" userId="9ad5295e-c011-431e-9933-da85a69d50eb" providerId="ADAL" clId="{FE312727-2FF1-41BE-81FD-03C074F4A432}" dt="2026-03-31T13:57:08.815" v="195" actId="207"/>
-          <ac:spMkLst>
-            <pc:docMk/>
-            <pc:sldMk cId="3140339783" sldId="266"/>
-            <ac:spMk id="16" creationId="{B201843C-2589-64BB-8E61-5AB911430817}"/>
-          </ac:spMkLst>
-        </pc:spChg>
-        <pc:spChg chg="add mod">
-          <ac:chgData name="Botond Szemes" userId="9ad5295e-c011-431e-9933-da85a69d50eb" providerId="ADAL" clId="{FE312727-2FF1-41BE-81FD-03C074F4A432}" dt="2026-03-31T14:41:31.318" v="510" actId="20577"/>
-          <ac:spMkLst>
-            <pc:docMk/>
-            <pc:sldMk cId="3140339783" sldId="266"/>
-            <ac:spMk id="17" creationId="{B5931919-0289-5AF4-EF15-90160C902059}"/>
-          </ac:spMkLst>
-        </pc:spChg>
-        <pc:spChg chg="add mod">
           <ac:chgData name="Botond Szemes" userId="9ad5295e-c011-431e-9933-da85a69d50eb" providerId="ADAL" clId="{FE312727-2FF1-41BE-81FD-03C074F4A432}" dt="2026-04-06T21:03:28.084" v="1061" actId="20577"/>
           <ac:spMkLst>
             <pc:docMk/>
             <pc:sldMk cId="3140339783" sldId="266"/>
             <ac:spMk id="20" creationId="{392F27E5-F9CE-8100-2D2A-370C39DD9F46}"/>
-          </ac:spMkLst>
-        </pc:spChg>
-        <pc:spChg chg="add mod">
-          <ac:chgData name="Botond Szemes" userId="9ad5295e-c011-431e-9933-da85a69d50eb" providerId="ADAL" clId="{FE312727-2FF1-41BE-81FD-03C074F4A432}" dt="2026-03-31T14:41:24.735" v="506" actId="1076"/>
-          <ac:spMkLst>
-            <pc:docMk/>
-            <pc:sldMk cId="3140339783" sldId="266"/>
-            <ac:spMk id="21" creationId="{49798EC7-67FA-54F2-7866-3014247E2AB6}"/>
-          </ac:spMkLst>
-        </pc:spChg>
-        <pc:spChg chg="add mod">
-          <ac:chgData name="Botond Szemes" userId="9ad5295e-c011-431e-9933-da85a69d50eb" providerId="ADAL" clId="{FE312727-2FF1-41BE-81FD-03C074F4A432}" dt="2026-03-31T14:39:23.760" v="486" actId="20577"/>
-          <ac:spMkLst>
-            <pc:docMk/>
-            <pc:sldMk cId="3140339783" sldId="266"/>
-            <ac:spMk id="22" creationId="{7E546030-3E4B-FE2A-481F-7937ADF5109C}"/>
-          </ac:spMkLst>
-        </pc:spChg>
-        <pc:spChg chg="add del mod">
-          <ac:chgData name="Botond Szemes" userId="9ad5295e-c011-431e-9933-da85a69d50eb" providerId="ADAL" clId="{FE312727-2FF1-41BE-81FD-03C074F4A432}" dt="2026-03-31T14:41:21.222" v="499" actId="20577"/>
-          <ac:spMkLst>
-            <pc:docMk/>
-            <pc:sldMk cId="3140339783" sldId="266"/>
-            <ac:spMk id="23" creationId="{BBC50E69-C58E-A7DA-64DC-050A464ED28F}"/>
-          </ac:spMkLst>
-        </pc:spChg>
-        <pc:spChg chg="add del mod">
-          <ac:chgData name="Botond Szemes" userId="9ad5295e-c011-431e-9933-da85a69d50eb" providerId="ADAL" clId="{FE312727-2FF1-41BE-81FD-03C074F4A432}" dt="2026-03-31T14:39:13.761" v="476" actId="20577"/>
-          <ac:spMkLst>
-            <pc:docMk/>
-            <pc:sldMk cId="3140339783" sldId="266"/>
-            <ac:spMk id="24" creationId="{3F339259-0539-F0DA-DA0F-EBDB90B58CF6}"/>
           </ac:spMkLst>
         </pc:spChg>
         <pc:spChg chg="add mod">
@@ -587,62 +419,6 @@
             <ac:spMk id="41" creationId="{6502CB3B-329E-26CD-2241-C7545C880581}"/>
           </ac:spMkLst>
         </pc:spChg>
-        <pc:picChg chg="add mod">
-          <ac:chgData name="Botond Szemes" userId="9ad5295e-c011-431e-9933-da85a69d50eb" providerId="ADAL" clId="{FE312727-2FF1-41BE-81FD-03C074F4A432}" dt="2026-03-31T13:55:06.064" v="159" actId="207"/>
-          <ac:picMkLst>
-            <pc:docMk/>
-            <pc:sldMk cId="3140339783" sldId="266"/>
-            <ac:picMk id="4" creationId="{0DF2DD20-6958-858E-4599-D747B5934727}"/>
-          </ac:picMkLst>
-        </pc:picChg>
-        <pc:cxnChg chg="add mod">
-          <ac:chgData name="Botond Szemes" userId="9ad5295e-c011-431e-9933-da85a69d50eb" providerId="ADAL" clId="{FE312727-2FF1-41BE-81FD-03C074F4A432}" dt="2026-03-31T14:00:35.557" v="228" actId="1076"/>
-          <ac:cxnSpMkLst>
-            <pc:docMk/>
-            <pc:sldMk cId="3140339783" sldId="266"/>
-            <ac:cxnSpMk id="19" creationId="{ACFEF152-E12C-AE99-7969-0A607EAD5B87}"/>
-          </ac:cxnSpMkLst>
-        </pc:cxnChg>
-        <pc:cxnChg chg="add mod">
-          <ac:chgData name="Botond Szemes" userId="9ad5295e-c011-431e-9933-da85a69d50eb" providerId="ADAL" clId="{FE312727-2FF1-41BE-81FD-03C074F4A432}" dt="2026-03-31T14:00:41.597" v="231" actId="14100"/>
-          <ac:cxnSpMkLst>
-            <pc:docMk/>
-            <pc:sldMk cId="3140339783" sldId="266"/>
-            <ac:cxnSpMk id="27" creationId="{9A4452D8-3FA0-A0D0-8881-9AE2E0A6F380}"/>
-          </ac:cxnSpMkLst>
-        </pc:cxnChg>
-        <pc:cxnChg chg="add mod">
-          <ac:chgData name="Botond Szemes" userId="9ad5295e-c011-431e-9933-da85a69d50eb" providerId="ADAL" clId="{FE312727-2FF1-41BE-81FD-03C074F4A432}" dt="2026-03-31T14:00:51.799" v="235" actId="14100"/>
-          <ac:cxnSpMkLst>
-            <pc:docMk/>
-            <pc:sldMk cId="3140339783" sldId="266"/>
-            <ac:cxnSpMk id="30" creationId="{C62AEA28-85CD-F328-860D-8E3AA08D919A}"/>
-          </ac:cxnSpMkLst>
-        </pc:cxnChg>
-        <pc:cxnChg chg="add mod">
-          <ac:chgData name="Botond Szemes" userId="9ad5295e-c011-431e-9933-da85a69d50eb" providerId="ADAL" clId="{FE312727-2FF1-41BE-81FD-03C074F4A432}" dt="2026-03-31T14:01:03.776" v="238" actId="14100"/>
-          <ac:cxnSpMkLst>
-            <pc:docMk/>
-            <pc:sldMk cId="3140339783" sldId="266"/>
-            <ac:cxnSpMk id="32" creationId="{E0B58686-D3FD-8579-315F-A901E887A52C}"/>
-          </ac:cxnSpMkLst>
-        </pc:cxnChg>
-        <pc:cxnChg chg="add mod">
-          <ac:chgData name="Botond Szemes" userId="9ad5295e-c011-431e-9933-da85a69d50eb" providerId="ADAL" clId="{FE312727-2FF1-41BE-81FD-03C074F4A432}" dt="2026-03-31T14:01:13.874" v="241" actId="14100"/>
-          <ac:cxnSpMkLst>
-            <pc:docMk/>
-            <pc:sldMk cId="3140339783" sldId="266"/>
-            <ac:cxnSpMk id="35" creationId="{C0E81DA3-652C-1658-D84A-86489CF6C1FA}"/>
-          </ac:cxnSpMkLst>
-        </pc:cxnChg>
-        <pc:cxnChg chg="add mod">
-          <ac:chgData name="Botond Szemes" userId="9ad5295e-c011-431e-9933-da85a69d50eb" providerId="ADAL" clId="{FE312727-2FF1-41BE-81FD-03C074F4A432}" dt="2026-03-31T14:01:20.219" v="244" actId="14100"/>
-          <ac:cxnSpMkLst>
-            <pc:docMk/>
-            <pc:sldMk cId="3140339783" sldId="266"/>
-            <ac:cxnSpMk id="38" creationId="{29712965-1378-E2EC-6E4A-D500C5119AC4}"/>
-          </ac:cxnSpMkLst>
-        </pc:cxnChg>
       </pc:sldChg>
       <pc:sldChg chg="addSp delSp modSp new mod delAnim modAnim">
         <pc:chgData name="Botond Szemes" userId="9ad5295e-c011-431e-9933-da85a69d50eb" providerId="ADAL" clId="{FE312727-2FF1-41BE-81FD-03C074F4A432}" dt="2026-04-09T13:44:36.435" v="3052" actId="20577"/>
@@ -2348,7 +2124,7 @@
           <a:p>
             <a:fld id="{4D95FDA6-6A52-430F-BC24-89803051C4CB}" type="datetimeFigureOut">
               <a:rPr lang="et-EE" smtClean="0"/>
-              <a:t>29.04.2026</a:t>
+              <a:t>01.05.2026</a:t>
             </a:fld>
             <a:endParaRPr lang="et-EE"/>
           </a:p>
@@ -2548,7 +2324,7 @@
           <a:p>
             <a:fld id="{4D95FDA6-6A52-430F-BC24-89803051C4CB}" type="datetimeFigureOut">
               <a:rPr lang="et-EE" smtClean="0"/>
-              <a:t>29.04.2026</a:t>
+              <a:t>01.05.2026</a:t>
             </a:fld>
             <a:endParaRPr lang="et-EE"/>
           </a:p>
@@ -2758,7 +2534,7 @@
           <a:p>
             <a:fld id="{4D95FDA6-6A52-430F-BC24-89803051C4CB}" type="datetimeFigureOut">
               <a:rPr lang="et-EE" smtClean="0"/>
-              <a:t>29.04.2026</a:t>
+              <a:t>01.05.2026</a:t>
             </a:fld>
             <a:endParaRPr lang="et-EE"/>
           </a:p>
@@ -2958,7 +2734,7 @@
           <a:p>
             <a:fld id="{4D95FDA6-6A52-430F-BC24-89803051C4CB}" type="datetimeFigureOut">
               <a:rPr lang="et-EE" smtClean="0"/>
-              <a:t>29.04.2026</a:t>
+              <a:t>01.05.2026</a:t>
             </a:fld>
             <a:endParaRPr lang="et-EE"/>
           </a:p>
@@ -3234,7 +3010,7 @@
           <a:p>
             <a:fld id="{4D95FDA6-6A52-430F-BC24-89803051C4CB}" type="datetimeFigureOut">
               <a:rPr lang="et-EE" smtClean="0"/>
-              <a:t>29.04.2026</a:t>
+              <a:t>01.05.2026</a:t>
             </a:fld>
             <a:endParaRPr lang="et-EE"/>
           </a:p>
@@ -3502,7 +3278,7 @@
           <a:p>
             <a:fld id="{4D95FDA6-6A52-430F-BC24-89803051C4CB}" type="datetimeFigureOut">
               <a:rPr lang="et-EE" smtClean="0"/>
-              <a:t>29.04.2026</a:t>
+              <a:t>01.05.2026</a:t>
             </a:fld>
             <a:endParaRPr lang="et-EE"/>
           </a:p>
@@ -3917,7 +3693,7 @@
           <a:p>
             <a:fld id="{4D95FDA6-6A52-430F-BC24-89803051C4CB}" type="datetimeFigureOut">
               <a:rPr lang="et-EE" smtClean="0"/>
-              <a:t>29.04.2026</a:t>
+              <a:t>01.05.2026</a:t>
             </a:fld>
             <a:endParaRPr lang="et-EE"/>
           </a:p>
@@ -4059,7 +3835,7 @@
           <a:p>
             <a:fld id="{4D95FDA6-6A52-430F-BC24-89803051C4CB}" type="datetimeFigureOut">
               <a:rPr lang="et-EE" smtClean="0"/>
-              <a:t>29.04.2026</a:t>
+              <a:t>01.05.2026</a:t>
             </a:fld>
             <a:endParaRPr lang="et-EE"/>
           </a:p>
@@ -4172,7 +3948,7 @@
           <a:p>
             <a:fld id="{4D95FDA6-6A52-430F-BC24-89803051C4CB}" type="datetimeFigureOut">
               <a:rPr lang="et-EE" smtClean="0"/>
-              <a:t>29.04.2026</a:t>
+              <a:t>01.05.2026</a:t>
             </a:fld>
             <a:endParaRPr lang="et-EE"/>
           </a:p>
@@ -4485,7 +4261,7 @@
           <a:p>
             <a:fld id="{4D95FDA6-6A52-430F-BC24-89803051C4CB}" type="datetimeFigureOut">
               <a:rPr lang="et-EE" smtClean="0"/>
-              <a:t>29.04.2026</a:t>
+              <a:t>01.05.2026</a:t>
             </a:fld>
             <a:endParaRPr lang="et-EE"/>
           </a:p>
@@ -4774,7 +4550,7 @@
           <a:p>
             <a:fld id="{4D95FDA6-6A52-430F-BC24-89803051C4CB}" type="datetimeFigureOut">
               <a:rPr lang="et-EE" smtClean="0"/>
-              <a:t>29.04.2026</a:t>
+              <a:t>01.05.2026</a:t>
             </a:fld>
             <a:endParaRPr lang="et-EE"/>
           </a:p>
@@ -5017,7 +4793,7 @@
           <a:p>
             <a:fld id="{4D95FDA6-6A52-430F-BC24-89803051C4CB}" type="datetimeFigureOut">
               <a:rPr lang="et-EE" smtClean="0"/>
-              <a:t>29.04.2026</a:t>
+              <a:t>01.05.2026</a:t>
             </a:fld>
             <a:endParaRPr lang="et-EE"/>
           </a:p>
@@ -21529,7 +21305,7 @@
         </p:spPr>
         <p:txBody>
           <a:bodyPr>
-            <a:normAutofit fontScale="70000" lnSpcReduction="20000"/>
+            <a:normAutofit fontScale="62500" lnSpcReduction="20000"/>
           </a:bodyPr>
           <a:lstStyle/>
           <a:p>
@@ -21655,6 +21431,20 @@
             <a:r>
               <a:rPr lang="et-EE" dirty="0"/>
               <a:t> 1.4</a:t>
+            </a:r>
+            <a:endParaRPr lang="hu-HU" dirty="0"/>
+          </a:p>
+          <a:p>
+            <a:pPr marL="0" indent="0" latinLnBrk="1">
+              <a:buNone/>
+            </a:pPr>
+            <a:r>
+              <a:rPr lang="hu-HU" b="1"/>
+              <a:t>Global Efficiency </a:t>
+            </a:r>
+            <a:r>
+              <a:rPr lang="hu-HU"/>
+              <a:t>(inverse of L)</a:t>
             </a:r>
             <a:endParaRPr lang="hu-HU" dirty="0"/>
           </a:p>

</xml_diff>